<commit_message>
Unify word usage about optional work / stage
</commit_message>
<xml_diff>
--- a/figures/fig_controller_interaction.pptx
+++ b/figures/fig_controller_interaction.pptx
@@ -2404,7 +2404,7 @@
               <a:buNone/>
             </a:pPr>
             <a:r>
-              <a:rPr sz="1200" b="1">
+              <a:rPr sz="1200" b="1" dirty="0">
                 <a:solidFill>
                   <a:srgbClr val="2476D2"/>
                 </a:solidFill>
@@ -2412,9 +2412,20 @@
                 <a:ea typeface="Arial"/>
                 <a:cs typeface="Arial"/>
               </a:rPr>
-              <a:t>Optional image processing</a:t>
+              <a:t>Optional </a:t>
             </a:r>
-            <a:endParaRPr sz="1200"/>
+            <a:r>
+              <a:rPr lang="en-US" sz="1200" b="1" dirty="0">
+                <a:solidFill>
+                  <a:srgbClr val="2476D2"/>
+                </a:solidFill>
+                <a:latin typeface="Arial"/>
+                <a:ea typeface="Arial"/>
+                <a:cs typeface="Arial"/>
+              </a:rPr>
+              <a:t>stages</a:t>
+            </a:r>
+            <a:endParaRPr sz="1200" dirty="0"/>
           </a:p>
         </p:txBody>
       </p:sp>

</xml_diff>